<commit_message>
Add dedicated Wind-Down feature (guided evening routine)
A separate "Wind-Down" option in the header opens a calm, guided end-of-day
sequence: intro → box-breathing → body settle → sleep-prep checklist (from the
sleep knowledge base) → a one-word reflection → a warm close. Self-contained
(works in the app and the static demo); completing it lightly rewards routine
consistency when a track is active. Styled in the Tactical Compassion palette.
Reflected on the deck's evening/SitRep slide. 22 tests still passing.

Co-Authored-By: Claude Opus 4.8 <noreply@anthropic.com>
</commit_message>
<xml_diff>
--- a/MindBridge-pitch-deck.pptx
+++ b/MindBridge-pitch-deck.pptx
@@ -5145,6 +5145,84 @@
           </a:p>
         </p:txBody>
       </p:sp>
+      <p:sp>
+        <p:nvSpPr>
+          <p:cNvPr id="20" name="Text 18"/>
+          <p:cNvSpPr/>
+          <p:nvPr/>
+        </p:nvSpPr>
+        <p:spPr>
+          <a:xfrm>
+            <a:off x="548640" y="5870448"/>
+            <a:ext cx="1097280" cy="274320"/>
+          </a:xfrm>
+          <a:prstGeom prst="rect">
+            <a:avLst/>
+          </a:prstGeom>
+          <a:noFill/>
+          <a:ln/>
+        </p:spPr>
+        <p:txBody>
+          <a:bodyPr wrap="square" lIns="0" tIns="0" rIns="0" bIns="0" rtlCol="0" anchor="ctr"/>
+          <a:lstStyle/>
+          <a:p>
+            <a:pPr indent="0" marL="0">
+              <a:buNone/>
+            </a:pPr>
+            <a:r>
+              <a:rPr lang="en-US" sz="1200" b="1" spc="100" kern="0" dirty="0">
+                <a:solidFill>
+                  <a:srgbClr val="B06A2C"/>
+                </a:solidFill>
+                <a:latin typeface="Courier New" pitchFamily="34" charset="0"/>
+                <a:ea typeface="Courier New" pitchFamily="34" charset="-122"/>
+                <a:cs typeface="Courier New" pitchFamily="34" charset="-120"/>
+              </a:rPr>
+              <a:t>PLUS</a:t>
+            </a:r>
+            <a:endParaRPr lang="en-US" sz="1200" dirty="0"/>
+          </a:p>
+        </p:txBody>
+      </p:sp>
+      <p:sp>
+        <p:nvSpPr>
+          <p:cNvPr id="21" name="Text 19"/>
+          <p:cNvSpPr/>
+          <p:nvPr/>
+        </p:nvSpPr>
+        <p:spPr>
+          <a:xfrm>
+            <a:off x="1371600" y="5824728"/>
+            <a:ext cx="10241280" cy="365760"/>
+          </a:xfrm>
+          <a:prstGeom prst="rect">
+            <a:avLst/>
+          </a:prstGeom>
+          <a:noFill/>
+          <a:ln/>
+        </p:spPr>
+        <p:txBody>
+          <a:bodyPr wrap="square" lIns="0" tIns="0" rIns="0" bIns="0" rtlCol="0" anchor="ctr"/>
+          <a:lstStyle/>
+          <a:p>
+            <a:pPr indent="0" marL="0">
+              <a:buNone/>
+            </a:pPr>
+            <a:r>
+              <a:rPr lang="en-US" sz="1400" i="1" dirty="0">
+                <a:solidFill>
+                  <a:srgbClr val="55665C"/>
+                </a:solidFill>
+                <a:latin typeface="Calibri" pitchFamily="34" charset="0"/>
+                <a:ea typeface="Calibri" pitchFamily="34" charset="-122"/>
+                <a:cs typeface="Calibri" pitchFamily="34" charset="-120"/>
+              </a:rPr>
+              <a:t>Every night, a guided Wind-Down — box-breathing plus sleep-prep — helps a veteran power the day down.</a:t>
+            </a:r>
+            <a:endParaRPr lang="en-US" sz="1400" dirty="0"/>
+          </a:p>
+        </p:txBody>
+      </p:sp>
     </p:spTree>
   </p:cSld>
   <p:clrMapOvr>

</xml_diff>